<commit_message>
Fix 3-fold CV wording, report/slide rounding, Fig. 2 caption; re-run notebook
</commit_message>
<xml_diff>
--- a/report/ML_Mini_Project_Presentation_62.pptx
+++ b/report/ML_Mini_Project_Presentation_62.pptx
@@ -2854,7 +2854,7 @@
           </a:prstGeom>
           <a:extLst>
             <a:ext uri="{C572A759-6A51-4108-AA02-DFA0A04FC94B}">
-              <ma14:wrappingTextBoxFlag xmlns:ma14="http://schemas.microsoft.com/office/mac/drawingml/2011/main" xmlns="" val="0"/>
+              <ma14:wrappingTextBoxFlag xmlns="" xmlns:ma14="http://schemas.microsoft.com/office/mac/drawingml/2011/main" val="0"/>
             </a:ext>
           </a:extLst>
         </p:spPr>
@@ -2929,7 +2929,7 @@
           </a:prstGeom>
           <a:extLst>
             <a:ext uri="{C572A759-6A51-4108-AA02-DFA0A04FC94B}">
-              <ma14:wrappingTextBoxFlag xmlns:ma14="http://schemas.microsoft.com/office/mac/drawingml/2011/main" xmlns="" val="0"/>
+              <ma14:wrappingTextBoxFlag xmlns="" xmlns:ma14="http://schemas.microsoft.com/office/mac/drawingml/2011/main" val="0"/>
             </a:ext>
           </a:extLst>
         </p:spPr>
@@ -3846,7 +3846,7 @@
           </a:prstGeom>
           <a:extLst>
             <a:ext uri="{C572A759-6A51-4108-AA02-DFA0A04FC94B}">
-              <ma14:wrappingTextBoxFlag xmlns:ma14="http://schemas.microsoft.com/office/mac/drawingml/2011/main" xmlns="" val="0"/>
+              <ma14:wrappingTextBoxFlag xmlns="" xmlns:ma14="http://schemas.microsoft.com/office/mac/drawingml/2011/main" val="0"/>
             </a:ext>
           </a:extLst>
         </p:spPr>
@@ -4222,7 +4222,7 @@
           </a:prstGeom>
           <a:extLst>
             <a:ext uri="{C572A759-6A51-4108-AA02-DFA0A04FC94B}">
-              <ma14:wrappingTextBoxFlag xmlns:ma14="http://schemas.microsoft.com/office/mac/drawingml/2011/main" xmlns="" val="0"/>
+              <ma14:wrappingTextBoxFlag xmlns="" xmlns:ma14="http://schemas.microsoft.com/office/mac/drawingml/2011/main" val="0"/>
             </a:ext>
           </a:extLst>
         </p:spPr>
@@ -4969,7 +4969,7 @@
           </a:prstGeom>
           <a:extLst>
             <a:ext uri="{C572A759-6A51-4108-AA02-DFA0A04FC94B}">
-              <ma14:wrappingTextBoxFlag xmlns:ma14="http://schemas.microsoft.com/office/mac/drawingml/2011/main" xmlns="" val="0"/>
+              <ma14:wrappingTextBoxFlag xmlns="" xmlns:ma14="http://schemas.microsoft.com/office/mac/drawingml/2011/main" val="0"/>
             </a:ext>
           </a:extLst>
         </p:spPr>
@@ -5782,7 +5782,7 @@
           </a:prstGeom>
           <a:extLst>
             <a:ext uri="{C572A759-6A51-4108-AA02-DFA0A04FC94B}">
-              <ma14:wrappingTextBoxFlag xmlns:ma14="http://schemas.microsoft.com/office/mac/drawingml/2011/main" xmlns="" val="0"/>
+              <ma14:wrappingTextBoxFlag xmlns="" xmlns:ma14="http://schemas.microsoft.com/office/mac/drawingml/2011/main" val="0"/>
             </a:ext>
           </a:extLst>
         </p:spPr>
@@ -6132,7 +6132,7 @@
           </a:prstGeom>
           <a:extLst>
             <a:ext uri="{C572A759-6A51-4108-AA02-DFA0A04FC94B}">
-              <ma14:wrappingTextBoxFlag xmlns:ma14="http://schemas.microsoft.com/office/mac/drawingml/2011/main" xmlns="" val="0"/>
+              <ma14:wrappingTextBoxFlag xmlns="" xmlns:ma14="http://schemas.microsoft.com/office/mac/drawingml/2011/main" val="0"/>
             </a:ext>
           </a:extLst>
         </p:spPr>
@@ -7086,7 +7086,7 @@
           </a:prstGeom>
           <a:extLst>
             <a:ext uri="{C572A759-6A51-4108-AA02-DFA0A04FC94B}">
-              <ma14:wrappingTextBoxFlag xmlns:ma14="http://schemas.microsoft.com/office/mac/drawingml/2011/main" xmlns="" val="0"/>
+              <ma14:wrappingTextBoxFlag xmlns="" xmlns:ma14="http://schemas.microsoft.com/office/mac/drawingml/2011/main" val="0"/>
             </a:ext>
           </a:extLst>
         </p:spPr>
@@ -7402,7 +7402,20 @@
                   <a:schemeClr val="tx1"/>
                 </a:solidFill>
               </a:rPr>
-              <a:t>Removing the other four lowers test R² by only 0.003 to 0.005.</a:t>
+              <a:t>Removing the other four lowers test R² by only 0.004</a:t>
+            </a:r>
+          </a:p>
+          <a:p>
+            <a:pPr marL="0" indent="0">
+              <a:buNone/>
+            </a:pPr>
+            <a:r>
+              <a:rPr lang="en-US" sz="1400" dirty="0">
+                <a:solidFill>
+                  <a:schemeClr val="tx1"/>
+                </a:solidFill>
+              </a:rPr>
+              <a:t> to 0.005.</a:t>
             </a:r>
             <a:endParaRPr lang="en-US" sz="1400" dirty="0"/>
           </a:p>
@@ -7500,7 +7513,7 @@
           </a:prstGeom>
           <a:extLst>
             <a:ext uri="{C572A759-6A51-4108-AA02-DFA0A04FC94B}">
-              <ma14:wrappingTextBoxFlag xmlns:ma14="http://schemas.microsoft.com/office/mac/drawingml/2011/main" xmlns="" val="0"/>
+              <ma14:wrappingTextBoxFlag xmlns="" xmlns:ma14="http://schemas.microsoft.com/office/mac/drawingml/2011/main" val="0"/>
             </a:ext>
           </a:extLst>
         </p:spPr>
@@ -8580,7 +8593,7 @@
           </a:prstGeom>
           <a:extLst>
             <a:ext uri="{C572A759-6A51-4108-AA02-DFA0A04FC94B}">
-              <ma14:wrappingTextBoxFlag xmlns:ma14="http://schemas.microsoft.com/office/mac/drawingml/2011/main" xmlns="" val="0"/>
+              <ma14:wrappingTextBoxFlag xmlns="" xmlns:ma14="http://schemas.microsoft.com/office/mac/drawingml/2011/main" val="0"/>
             </a:ext>
           </a:extLst>
         </p:spPr>
@@ -10488,7 +10501,7 @@
           </a:prstGeom>
           <a:extLst>
             <a:ext uri="{C572A759-6A51-4108-AA02-DFA0A04FC94B}">
-              <ma14:wrappingTextBoxFlag xmlns:ma14="http://schemas.microsoft.com/office/mac/drawingml/2011/main" xmlns="" val="0"/>
+              <ma14:wrappingTextBoxFlag xmlns="" xmlns:ma14="http://schemas.microsoft.com/office/mac/drawingml/2011/main" val="0"/>
             </a:ext>
           </a:extLst>
         </p:spPr>
@@ -10766,7 +10779,7 @@
           </a:prstGeom>
           <a:extLst>
             <a:ext uri="{C572A759-6A51-4108-AA02-DFA0A04FC94B}">
-              <ma14:wrappingTextBoxFlag xmlns:ma14="http://schemas.microsoft.com/office/mac/drawingml/2011/main" xmlns="" val="0"/>
+              <ma14:wrappingTextBoxFlag xmlns="" xmlns:ma14="http://schemas.microsoft.com/office/mac/drawingml/2011/main" val="0"/>
             </a:ext>
           </a:extLst>
         </p:spPr>

</xml_diff>